<commit_message>
Terianix in the engagement presentation
</commit_message>
<xml_diff>
--- a/blob_templates/award_nomination_onboarding_template.pptx
+++ b/blob_templates/award_nomination_onboarding_template.pptx
@@ -1994,7 +1994,7 @@
                 <a:ea typeface="Calibri" pitchFamily="34" charset="-122"/>
                 <a:cs typeface="Calibri" pitchFamily="34" charset="-120"/>
               </a:rPr>
-              <a:t>Provided by:  Terian Services</a:t>
+              <a:t>Provided by:  Terianix.ai</a:t>
             </a:r>
             <a:endParaRPr lang="en-US" sz="1000" dirty="0"/>
           </a:p>
@@ -2316,7 +2316,7 @@
                 <a:ea typeface="Calibri" pitchFamily="34" charset="-122"/>
                 <a:cs typeface="Calibri" pitchFamily="34" charset="-120"/>
               </a:rPr>
-              <a:t>terian-services.com  |  sales@terian-services.com</a:t>
+              <a:t>terianix.ai  |  sales@terian-services.com</a:t>
             </a:r>
             <a:endParaRPr lang="en-US" sz="900" dirty="0"/>
           </a:p>
@@ -2413,7 +2413,7 @@
                 <a:ea typeface="Calibri" pitchFamily="34" charset="-122"/>
                 <a:cs typeface="Calibri" pitchFamily="34" charset="-120"/>
               </a:rPr>
-              <a:t>Provided by:  Terian Services</a:t>
+              <a:t>Provided by:  Terianix.ai</a:t>
             </a:r>
             <a:endParaRPr lang="en-US" sz="1000" dirty="0"/>
           </a:p>
@@ -3872,7 +3872,7 @@
                 <a:ea typeface="Calibri" pitchFamily="34" charset="-122"/>
                 <a:cs typeface="Calibri" pitchFamily="34" charset="-120"/>
               </a:rPr>
-              <a:t>Provided by:  Terian Services</a:t>
+              <a:t>Provided by:  Terianix.ai</a:t>
             </a:r>
             <a:endParaRPr lang="en-US" sz="1000" dirty="0"/>
           </a:p>
@@ -4288,7 +4288,7 @@
                 <a:ea typeface="Calibri" pitchFamily="34" charset="-122"/>
                 <a:cs typeface="Calibri" pitchFamily="34" charset="-120"/>
               </a:rPr>
-              <a:t>Terian Services creates the tenant DB record, provisions the custom subdomain ({{CLIENT_SUBDOMAIN}}.terian-services.com), and configures DNS.</a:t>
+              <a:t>Terianix.ai creates the tenant DB record, provisions the custom subdomain ({{CLIENT_SUBDOMAIN}}-awards.terianix.ai), and configures DNS.</a:t>
             </a:r>
             <a:endParaRPr lang="en-US" sz="1000" dirty="0"/>
           </a:p>
@@ -4795,7 +4795,7 @@
                 <a:ea typeface="Calibri" pitchFamily="34" charset="-122"/>
                 <a:cs typeface="Calibri" pitchFamily="34" charset="-120"/>
               </a:rPr>
-              <a:t>✓  {{CLIENT_SUBDOMAIN}}.terian-services.com live</a:t>
+              <a:t>✓  {{CLIENT_SUBDOMAIN}}-awards.terianix.ai live</a:t>
             </a:r>
             <a:endParaRPr lang="en-US" sz="1050" dirty="0"/>
           </a:p>
@@ -5010,7 +5010,7 @@
                 <a:ea typeface="Calibri" pitchFamily="34" charset="-122"/>
                 <a:cs typeface="Calibri" pitchFamily="34" charset="-120"/>
               </a:rPr>
-              <a:t>Terian Services manages all provisioning tasks. {{CLIENT_NAME}} provides: Azure AD tenant ID, brand assets (logo, hex colour), and employee CSV. No infrastructure setup required on your side.</a:t>
+              <a:t>Terianix.ai manages all provisioning tasks. {{CLIENT_NAME}} provides: Azure AD tenant ID, brand assets (logo, hex colour), and employee CSV. No infrastructure setup required on your side.</a:t>
             </a:r>
             <a:endParaRPr lang="en-US" sz="1000" dirty="0"/>
           </a:p>
@@ -5107,7 +5107,7 @@
                 <a:ea typeface="Calibri" pitchFamily="34" charset="-122"/>
                 <a:cs typeface="Calibri" pitchFamily="34" charset="-120"/>
               </a:rPr>
-              <a:t>Provided by:  Terian Services</a:t>
+              <a:t>Provided by:  Terianix.ai</a:t>
             </a:r>
             <a:endParaRPr lang="en-US" sz="1000" dirty="0"/>
           </a:p>
@@ -5588,7 +5588,7 @@
                 <a:ea typeface="Calibri" pitchFamily="34" charset="-122"/>
                 <a:cs typeface="Calibri" pitchFamily="34" charset="-120"/>
               </a:rPr>
-              <a:t>Terian resolves all raised issues within SLA. Formal sign-off document issued.</a:t>
+              <a:t>Terianix.ai resolves all raised issues within SLA. Formal sign-off document issued.</a:t>
             </a:r>
             <a:endParaRPr lang="en-US" sz="950" dirty="0"/>
           </a:p>
@@ -6480,7 +6480,7 @@
                 <a:ea typeface="Calibri" pitchFamily="34" charset="-122"/>
                 <a:cs typeface="Calibri" pitchFamily="34" charset="-120"/>
               </a:rPr>
-              <a:t>Provided by:  Terian Services</a:t>
+              <a:t>Provided by:  Terianix.ai</a:t>
             </a:r>
             <a:endParaRPr lang="en-US" sz="1000" dirty="0"/>
           </a:p>
@@ -7822,7 +7822,7 @@
                 <a:ea typeface="Calibri" pitchFamily="34" charset="-122"/>
                 <a:cs typeface="Calibri" pitchFamily="34" charset="-120"/>
               </a:rPr>
-              <a:t>Application bugs and incident resolution  </a:t>
+              <a:t xml:space="preserve">Application bugs and incident resolution  </a:t>
             </a:r>
             <a:endParaRPr lang="en-US" sz="950" dirty="0"/>
           </a:p>
@@ -7840,7 +7840,7 @@
                 <a:ea typeface="Calibri" pitchFamily="34" charset="-122"/>
                 <a:cs typeface="Calibri" pitchFamily="34" charset="-120"/>
               </a:rPr>
-              <a:t>User and admin account management  </a:t>
+              <a:t xml:space="preserve">User and admin account management  </a:t>
             </a:r>
             <a:endParaRPr lang="en-US" sz="950" dirty="0"/>
           </a:p>
@@ -7858,7 +7858,7 @@
                 <a:ea typeface="Calibri" pitchFamily="34" charset="-122"/>
                 <a:cs typeface="Calibri" pitchFamily="34" charset="-120"/>
               </a:rPr>
-              <a:t>Fraud model retraining (quarterly or on demand)  </a:t>
+              <a:t xml:space="preserve">Fraud model retraining (quarterly or on demand)  </a:t>
             </a:r>
             <a:endParaRPr lang="en-US" sz="950" dirty="0"/>
           </a:p>
@@ -7876,7 +7876,7 @@
                 <a:ea typeface="Calibri" pitchFamily="34" charset="-122"/>
                 <a:cs typeface="Calibri" pitchFamily="34" charset="-120"/>
               </a:rPr>
-              <a:t>Minor configuration changes (locale, theme, roles)  </a:t>
+              <a:t xml:space="preserve">Minor configuration changes (locale, theme, roles)  </a:t>
             </a:r>
             <a:endParaRPr lang="en-US" sz="950" dirty="0"/>
           </a:p>
@@ -7980,7 +7980,7 @@
                 <a:ea typeface="Calibri" pitchFamily="34" charset="-122"/>
                 <a:cs typeface="Calibri" pitchFamily="34" charset="-120"/>
               </a:rPr>
-              <a:t>Scheduled: Sundays 02:00–04:00 UTC  </a:t>
+              <a:t xml:space="preserve">Scheduled: Sundays 02:00–04:00 UTC  </a:t>
             </a:r>
             <a:endParaRPr lang="en-US" sz="950" dirty="0"/>
           </a:p>
@@ -7998,7 +7998,7 @@
                 <a:ea typeface="Calibri" pitchFamily="34" charset="-122"/>
                 <a:cs typeface="Calibri" pitchFamily="34" charset="-120"/>
               </a:rPr>
-              <a:t>48-hour advance notice for planned downtime  </a:t>
+              <a:t xml:space="preserve">48-hour advance notice for planned downtime  </a:t>
             </a:r>
             <a:endParaRPr lang="en-US" sz="950" dirty="0"/>
           </a:p>
@@ -8016,7 +8016,7 @@
                 <a:ea typeface="Calibri" pitchFamily="34" charset="-122"/>
                 <a:cs typeface="Calibri" pitchFamily="34" charset="-120"/>
               </a:rPr>
-              <a:t>Zero-downtime deploys via blue/green (target)  </a:t>
+              <a:t xml:space="preserve">Zero-downtime deploys via blue/green (target)  </a:t>
             </a:r>
             <a:endParaRPr lang="en-US" sz="950" dirty="0"/>
           </a:p>
@@ -8034,7 +8034,7 @@
                 <a:ea typeface="Calibri" pitchFamily="34" charset="-122"/>
                 <a:cs typeface="Calibri" pitchFamily="34" charset="-120"/>
               </a:rPr>
-              <a:t>Emergency patches applied outside windows as needed  </a:t>
+              <a:t xml:space="preserve">Emergency patches applied outside windows as needed  </a:t>
             </a:r>
             <a:endParaRPr lang="en-US" sz="950" dirty="0"/>
           </a:p>
@@ -8131,7 +8131,7 @@
                 <a:ea typeface="Calibri" pitchFamily="34" charset="-122"/>
                 <a:cs typeface="Calibri" pitchFamily="34" charset="-120"/>
               </a:rPr>
-              <a:t>Provided by:  Terian Services</a:t>
+              <a:t>Provided by:  Terianix.ai</a:t>
             </a:r>
             <a:endParaRPr lang="en-US" sz="1000" dirty="0"/>
           </a:p>
@@ -8417,7 +8417,7 @@
                 <a:ea typeface="Calibri" pitchFamily="34" charset="-122"/>
                 <a:cs typeface="Calibri" pitchFamily="34" charset="-120"/>
               </a:rPr>
-              <a:t>Sign the Terian Services SaaS Pilot Agreement (30-day no-obligation pilot). No infrastructure commitment required. Covers data privacy, uptime commitment, and support scope.</a:t>
+              <a:t>Sign the Terianix.ai SaaS Pilot Agreement (30-day no-obligation pilot). No infrastructure commitment required. Covers data privacy, uptime commitment, and support scope.</a:t>
             </a:r>
             <a:endParaRPr lang="en-US" sz="1000" dirty="0"/>
           </a:p>
@@ -8586,7 +8586,7 @@
                 <a:ea typeface="Calibri" pitchFamily="34" charset="-122"/>
                 <a:cs typeface="Calibri" pitchFamily="34" charset="-120"/>
               </a:rPr>
-              <a:t>Share your Azure AD tenant ID, primary brand colour (hex), company logo (PNG), and an employee CSV (name, email, manager email). Terian handles everything from there.</a:t>
+              <a:t>Share your Azure AD tenant ID, primary brand colour (hex), company logo (PNG), and an employee CSV (name, email, manager email). Terianix.ai handles everything from there.</a:t>
             </a:r>
             <a:endParaRPr lang="en-US" sz="1000" dirty="0"/>
           </a:p>
@@ -8755,7 +8755,7 @@
                 <a:ea typeface="Calibri" pitchFamily="34" charset="-122"/>
                 <a:cs typeface="Calibri" pitchFamily="34" charset="-120"/>
               </a:rPr>
-              <a:t>Schedule a 60-minute kick-off call with Terian Services. We'll confirm all requirements, walk through the sandbox live, and set the go-live target date.</a:t>
+              <a:t>Schedule a 60-minute kick-off call with Terianix.ai. We'll confirm all requirements, walk through the sandbox live, and set the go-live target date.</a:t>
             </a:r>
             <a:endParaRPr lang="en-US" sz="1000" dirty="0"/>
           </a:p>
@@ -8819,7 +8819,7 @@
                 <a:ea typeface="Calibri" pitchFamily="34" charset="-122"/>
                 <a:cs typeface="Calibri" pitchFamily="34" charset="-120"/>
               </a:rPr>
-              <a:t>Contact:  Terian Services  ·  sales@terian-services.com  ·  terian-services.com</a:t>
+              <a:t>Contact:  Terianix.ai  ·  sales@terian-services.com  ·  terianix.ai</a:t>
             </a:r>
             <a:endParaRPr lang="en-US" sz="1050" dirty="0"/>
           </a:p>
@@ -8966,7 +8966,7 @@
                 <a:ea typeface="Calibri" pitchFamily="34" charset="-122"/>
                 <a:cs typeface="Calibri" pitchFamily="34" charset="-120"/>
               </a:rPr>
-              <a:t>Provided by:  Terian Services</a:t>
+              <a:t>Provided by:  Terianix.ai</a:t>
             </a:r>
             <a:endParaRPr lang="en-US" sz="1000" dirty="0"/>
           </a:p>
@@ -9288,7 +9288,7 @@
                 <a:ea typeface="Calibri" pitchFamily="34" charset="-122"/>
                 <a:cs typeface="Calibri" pitchFamily="34" charset="-120"/>
               </a:rPr>
-              <a:t>terian-services.com</a:t>
+              <a:t>terianix.ai</a:t>
             </a:r>
             <a:endParaRPr lang="en-US" sz="1300" dirty="0"/>
           </a:p>
@@ -9449,7 +9449,7 @@
                 <a:ea typeface="Calibri" pitchFamily="34" charset="-122"/>
                 <a:cs typeface="Calibri" pitchFamily="34" charset="-120"/>
               </a:rPr>
-              <a:t>Provided by: Terian Services</a:t>
+              <a:t>Provided by: Terianix.ai</a:t>
             </a:r>
             <a:endParaRPr lang="en-US" sz="1100" dirty="0"/>
           </a:p>
@@ -9655,7 +9655,7 @@
                 <a:ea typeface="Calibri" pitchFamily="34" charset="-122"/>
                 <a:cs typeface="Calibri" pitchFamily="34" charset="-120"/>
               </a:rPr>
-              <a:t>CONFIDENTIAL — {{CLIENT_NAME}} Onboarding  |  © 2025 Terian Services</a:t>
+              <a:t>CONFIDENTIAL — {{CLIENT_NAME}} Onboarding  |  © 2025 Terianix.ai</a:t>
             </a:r>
             <a:endParaRPr lang="en-US" sz="750" dirty="0"/>
           </a:p>
@@ -9777,7 +9777,7 @@
                 <a:ea typeface="Calibri" pitchFamily="34" charset="-122"/>
                 <a:cs typeface="Calibri" pitchFamily="34" charset="-120"/>
               </a:rPr>
-              <a:t>Provided by: Terian Services</a:t>
+              <a:t>Provided by: Terianix.ai</a:t>
             </a:r>
             <a:endParaRPr lang="en-US" sz="1100" dirty="0"/>
           </a:p>
@@ -10209,7 +10209,7 @@
                 <a:ea typeface="Calibri" pitchFamily="34" charset="-122"/>
                 <a:cs typeface="Calibri" pitchFamily="34" charset="-120"/>
               </a:rPr>
-              <a:t>CONFIDENTIAL — {{CLIENT_NAME}} Onboarding  |  © 2025 Terian Services</a:t>
+              <a:t>CONFIDENTIAL — {{CLIENT_NAME}} Onboarding  |  © 2025 Terianix.ai</a:t>
             </a:r>
             <a:endParaRPr lang="en-US" sz="750" dirty="0"/>
           </a:p>
@@ -10331,7 +10331,7 @@
                 <a:ea typeface="Calibri" pitchFamily="34" charset="-122"/>
                 <a:cs typeface="Calibri" pitchFamily="34" charset="-120"/>
               </a:rPr>
-              <a:t>Provided by: Terian Services</a:t>
+              <a:t>Provided by: Terianix.ai</a:t>
             </a:r>
             <a:endParaRPr lang="en-US" sz="1100" dirty="0"/>
           </a:p>
@@ -10611,7 +10611,7 @@
                 <a:ea typeface="Calibri" pitchFamily="34" charset="-122"/>
                 <a:cs typeface="Calibri" pitchFamily="34" charset="-120"/>
               </a:rPr>
-              <a:t>CONFIDENTIAL — {{CLIENT_NAME}} Onboarding  |  © 2025 Terian Services</a:t>
+              <a:t>CONFIDENTIAL — {{CLIENT_NAME}} Onboarding  |  © 2025 Terianix.ai</a:t>
             </a:r>
             <a:endParaRPr lang="en-US" sz="750" dirty="0"/>
           </a:p>
@@ -10733,7 +10733,7 @@
                 <a:ea typeface="Calibri" pitchFamily="34" charset="-122"/>
                 <a:cs typeface="Calibri" pitchFamily="34" charset="-120"/>
               </a:rPr>
-              <a:t>Provided by: Terian Services</a:t>
+              <a:t>Provided by: Terianix.ai</a:t>
             </a:r>
             <a:endParaRPr lang="en-US" sz="1100" dirty="0"/>
           </a:p>
@@ -11013,7 +11013,7 @@
                 <a:ea typeface="Calibri" pitchFamily="34" charset="-122"/>
                 <a:cs typeface="Calibri" pitchFamily="34" charset="-120"/>
               </a:rPr>
-              <a:t>CONFIDENTIAL — {{CLIENT_NAME}} Onboarding  |  © 2025 Terian Services</a:t>
+              <a:t>CONFIDENTIAL — {{CLIENT_NAME}} Onboarding  |  © 2025 Terianix.ai</a:t>
             </a:r>
             <a:endParaRPr lang="en-US" sz="750" dirty="0"/>
           </a:p>
@@ -11110,7 +11110,7 @@
                 <a:ea typeface="Calibri" pitchFamily="34" charset="-122"/>
                 <a:cs typeface="Calibri" pitchFamily="34" charset="-120"/>
               </a:rPr>
-              <a:t>Provided by:  Terian Services</a:t>
+              <a:t>Provided by:  Terianix.ai</a:t>
             </a:r>
             <a:endParaRPr lang="en-US" sz="1000" dirty="0"/>
           </a:p>
@@ -12343,7 +12343,7 @@
                 <a:ea typeface="Calibri" pitchFamily="34" charset="-122"/>
                 <a:cs typeface="Calibri" pitchFamily="34" charset="-120"/>
               </a:rPr>
-              <a:t>Provided by: Terian Services</a:t>
+              <a:t>Provided by: Terianix.ai</a:t>
             </a:r>
             <a:endParaRPr lang="en-US" sz="1100" dirty="0"/>
           </a:p>
@@ -12623,7 +12623,7 @@
                 <a:ea typeface="Calibri" pitchFamily="34" charset="-122"/>
                 <a:cs typeface="Calibri" pitchFamily="34" charset="-120"/>
               </a:rPr>
-              <a:t>CONFIDENTIAL — {{CLIENT_NAME}} Onboarding  |  © 2025 Terian Services</a:t>
+              <a:t>CONFIDENTIAL — {{CLIENT_NAME}} Onboarding  |  © 2025 Terianix.ai</a:t>
             </a:r>
             <a:endParaRPr lang="en-US" sz="750" dirty="0"/>
           </a:p>
@@ -12745,7 +12745,7 @@
                 <a:ea typeface="Calibri" pitchFamily="34" charset="-122"/>
                 <a:cs typeface="Calibri" pitchFamily="34" charset="-120"/>
               </a:rPr>
-              <a:t>Provided by: Terian Services</a:t>
+              <a:t>Provided by: Terianix.ai</a:t>
             </a:r>
             <a:endParaRPr lang="en-US" sz="1100" dirty="0"/>
           </a:p>
@@ -13025,7 +13025,7 @@
                 <a:ea typeface="Calibri" pitchFamily="34" charset="-122"/>
                 <a:cs typeface="Calibri" pitchFamily="34" charset="-120"/>
               </a:rPr>
-              <a:t>CONFIDENTIAL — {{CLIENT_NAME}} Onboarding  |  © 2025 Terian Services</a:t>
+              <a:t>CONFIDENTIAL — {{CLIENT_NAME}} Onboarding  |  © 2025 Terianix.ai</a:t>
             </a:r>
             <a:endParaRPr lang="en-US" sz="750" dirty="0"/>
           </a:p>
@@ -13147,7 +13147,7 @@
                 <a:ea typeface="Calibri" pitchFamily="34" charset="-122"/>
                 <a:cs typeface="Calibri" pitchFamily="34" charset="-120"/>
               </a:rPr>
-              <a:t>Provided by: Terian Services</a:t>
+              <a:t>Provided by: Terianix.ai</a:t>
             </a:r>
             <a:endParaRPr lang="en-US" sz="1100" dirty="0"/>
           </a:p>
@@ -13427,7 +13427,7 @@
                 <a:ea typeface="Calibri" pitchFamily="34" charset="-122"/>
                 <a:cs typeface="Calibri" pitchFamily="34" charset="-120"/>
               </a:rPr>
-              <a:t>CONFIDENTIAL — {{CLIENT_NAME}} Onboarding  |  © 2025 Terian Services</a:t>
+              <a:t>CONFIDENTIAL — {{CLIENT_NAME}} Onboarding  |  © 2025 Terianix.ai</a:t>
             </a:r>
             <a:endParaRPr lang="en-US" sz="750" dirty="0"/>
           </a:p>
@@ -13549,7 +13549,7 @@
                 <a:ea typeface="Calibri" pitchFamily="34" charset="-122"/>
                 <a:cs typeface="Calibri" pitchFamily="34" charset="-120"/>
               </a:rPr>
-              <a:t>Provided by: Terian Services</a:t>
+              <a:t>Provided by: Terianix.ai</a:t>
             </a:r>
             <a:endParaRPr lang="en-US" sz="1100" dirty="0"/>
           </a:p>
@@ -13829,7 +13829,7 @@
                 <a:ea typeface="Calibri" pitchFamily="34" charset="-122"/>
                 <a:cs typeface="Calibri" pitchFamily="34" charset="-120"/>
               </a:rPr>
-              <a:t>CONFIDENTIAL — {{CLIENT_NAME}} Onboarding  |  © 2025 Terian Services</a:t>
+              <a:t>CONFIDENTIAL — {{CLIENT_NAME}} Onboarding  |  © 2025 Terianix.ai</a:t>
             </a:r>
             <a:endParaRPr lang="en-US" sz="750" dirty="0"/>
           </a:p>
@@ -13951,7 +13951,7 @@
                 <a:ea typeface="Calibri" pitchFamily="34" charset="-122"/>
                 <a:cs typeface="Calibri" pitchFamily="34" charset="-120"/>
               </a:rPr>
-              <a:t>Provided by: Terian Services</a:t>
+              <a:t>Provided by: Terianix.ai</a:t>
             </a:r>
             <a:endParaRPr lang="en-US" sz="1100" dirty="0"/>
           </a:p>
@@ -14231,7 +14231,7 @@
                 <a:ea typeface="Calibri" pitchFamily="34" charset="-122"/>
                 <a:cs typeface="Calibri" pitchFamily="34" charset="-120"/>
               </a:rPr>
-              <a:t>CONFIDENTIAL — {{CLIENT_NAME}} Onboarding  |  © 2025 Terian Services</a:t>
+              <a:t>CONFIDENTIAL — {{CLIENT_NAME}} Onboarding  |  © 2025 Terianix.ai</a:t>
             </a:r>
             <a:endParaRPr lang="en-US" sz="750" dirty="0"/>
           </a:p>
@@ -14326,7 +14326,7 @@
                 </a:solidFill>
                 <a:latin typeface="Calibri" pitchFamily="34" charset="0"/>
               </a:rPr>
-              <a:t>Provided by:  Terian Services</a:t>
+              <a:t>Provided by:  Terianix.ai</a:t>
             </a:r>
             <a:endParaRPr lang="en-US" sz="1000" dirty="0"/>
           </a:p>
@@ -15767,7 +15767,7 @@
                 </a:solidFill>
                 <a:latin typeface="Calibri" pitchFamily="34" charset="0"/>
               </a:rPr>
-              <a:t>Provided by:  Terian Services</a:t>
+              <a:t>Provided by:  Terianix.ai</a:t>
             </a:r>
           </a:p>
         </p:txBody>
@@ -15978,7 +15978,7 @@
                 </a:solidFill>
                 <a:latin typeface="Calibri" pitchFamily="34" charset="0"/>
               </a:rPr>
-              <a:t>Provided by:  Terian Services</a:t>
+              <a:t>Provided by:  Terianix.ai</a:t>
             </a:r>
           </a:p>
         </p:txBody>
@@ -17039,7 +17039,7 @@
                 </a:solidFill>
                 <a:latin typeface="Calibri" pitchFamily="34" charset="0"/>
               </a:rPr>
-              <a:t>Provided by:  Terian Services</a:t>
+              <a:t>Provided by:  Terianix.ai</a:t>
             </a:r>
           </a:p>
         </p:txBody>
@@ -17975,7 +17975,7 @@
                 <a:ea typeface="Calibri" pitchFamily="34" charset="-122"/>
                 <a:cs typeface="Calibri" pitchFamily="34" charset="-120"/>
               </a:rPr>
-              <a:t>Provided by:  Terian Services</a:t>
+              <a:t>Provided by:  Terianix.ai</a:t>
             </a:r>
             <a:endParaRPr lang="en-US" sz="1000" dirty="0"/>
           </a:p>
@@ -19297,7 +19297,7 @@
                 <a:ea typeface="Calibri" pitchFamily="34" charset="-122"/>
                 <a:cs typeface="Calibri" pitchFamily="34" charset="-120"/>
               </a:rPr>
-              <a:t>Provided by:  Terian Services</a:t>
+              <a:t>Provided by:  Terianix.ai</a:t>
             </a:r>
             <a:endParaRPr lang="en-US" sz="1000" dirty="0"/>
           </a:p>
@@ -20287,7 +20287,7 @@
                 <a:ea typeface="Calibri" pitchFamily="34" charset="-122"/>
                 <a:cs typeface="Calibri" pitchFamily="34" charset="-120"/>
               </a:rPr>
-              <a:t>Provided by:  Terian Services</a:t>
+              <a:t>Provided by:  Terianix.ai</a:t>
             </a:r>
             <a:endParaRPr lang="en-US" sz="1000" dirty="0"/>
           </a:p>
@@ -20535,7 +20535,7 @@
                 <a:ea typeface="Calibri" pitchFamily="34" charset="-122"/>
                 <a:cs typeface="Calibri" pitchFamily="34" charset="-120"/>
               </a:rPr>
-              <a:t>High nomination frequency  </a:t>
+              <a:t xml:space="preserve">High nomination frequency  </a:t>
             </a:r>
             <a:endParaRPr lang="en-US" sz="1100" dirty="0"/>
           </a:p>
@@ -20553,7 +20553,7 @@
                 <a:ea typeface="Calibri" pitchFamily="34" charset="-122"/>
                 <a:cs typeface="Calibri" pitchFamily="34" charset="-120"/>
               </a:rPr>
-              <a:t>Repeated beneficiary patterns  </a:t>
+              <a:t xml:space="preserve">Repeated beneficiary patterns  </a:t>
             </a:r>
             <a:endParaRPr lang="en-US" sz="1100" dirty="0"/>
           </a:p>
@@ -20571,7 +20571,7 @@
                 <a:ea typeface="Calibri" pitchFamily="34" charset="-122"/>
                 <a:cs typeface="Calibri" pitchFamily="34" charset="-120"/>
               </a:rPr>
-              <a:t>Circular / reciprocal schemes  </a:t>
+              <a:t xml:space="preserve">Circular / reciprocal schemes  </a:t>
             </a:r>
             <a:endParaRPr lang="en-US" sz="1100" dirty="0"/>
           </a:p>
@@ -20589,7 +20589,7 @@
                 <a:ea typeface="Calibri" pitchFamily="34" charset="-122"/>
                 <a:cs typeface="Calibri" pitchFamily="34" charset="-120"/>
               </a:rPr>
-              <a:t>Unusually high amounts (&gt; 2σ from baseline)  </a:t>
+              <a:t xml:space="preserve">Unusually high amounts (&gt; 2σ from baseline)  </a:t>
             </a:r>
             <a:endParaRPr lang="en-US" sz="1100" dirty="0"/>
           </a:p>
@@ -20607,7 +20607,7 @@
                 <a:ea typeface="Calibri" pitchFamily="34" charset="-122"/>
                 <a:cs typeface="Calibri" pitchFamily="34" charset="-120"/>
               </a:rPr>
-              <a:t>Rapid approvals (&lt; 1 hour)  </a:t>
+              <a:t xml:space="preserve">Rapid approvals (&lt; 1 hour)  </a:t>
             </a:r>
             <a:endParaRPr lang="en-US" sz="1100" dirty="0"/>
           </a:p>
@@ -20625,7 +20625,7 @@
                 <a:ea typeface="Calibri" pitchFamily="34" charset="-122"/>
                 <a:cs typeface="Calibri" pitchFamily="34" charset="-120"/>
               </a:rPr>
-              <a:t>Self-dealing network detection  </a:t>
+              <a:t xml:space="preserve">Self-dealing network detection  </a:t>
             </a:r>
             <a:endParaRPr lang="en-US" sz="1100" dirty="0"/>
           </a:p>
@@ -21400,7 +21400,7 @@
                 <a:ea typeface="Calibri" pitchFamily="34" charset="-122"/>
                 <a:cs typeface="Calibri" pitchFamily="34" charset="-120"/>
               </a:rPr>
-              <a:t>Provided by:  Terian Services</a:t>
+              <a:t>Provided by:  Terianix.ai</a:t>
             </a:r>
             <a:endParaRPr lang="en-US" sz="1000" dirty="0"/>
           </a:p>
@@ -22296,7 +22296,7 @@
                 <a:ea typeface="Calibri" pitchFamily="34" charset="-122"/>
                 <a:cs typeface="Calibri" pitchFamily="34" charset="-120"/>
               </a:rPr>
-              <a:t>Provided by:  Terian Services</a:t>
+              <a:t>Provided by:  Terianix.ai</a:t>
             </a:r>
             <a:endParaRPr lang="en-US" sz="1000" dirty="0"/>
           </a:p>
@@ -23039,7 +23039,7 @@
                 <a:ea typeface="Calibri" pitchFamily="34" charset="-122"/>
                 <a:cs typeface="Calibri" pitchFamily="34" charset="-120"/>
               </a:rPr>
-              <a:t>Provided by:  Terian Services</a:t>
+              <a:t>Provided by:  Terianix.ai</a:t>
             </a:r>
             <a:endParaRPr lang="en-US" sz="1000" dirty="0"/>
           </a:p>
@@ -23350,7 +23350,7 @@
                 <a:ea typeface="Calibri" pitchFamily="34" charset="-122"/>
                 <a:cs typeface="Calibri" pitchFamily="34" charset="-120"/>
               </a:rPr>
-              <a:t>{{CLIENT_SUBDOMAIN}}.terian-services.com</a:t>
+              <a:t>{{CLIENT_SUBDOMAIN}}-awards.terianix.ai</a:t>
             </a:r>
             <a:endParaRPr lang="en-US" sz="1050" dirty="0"/>
           </a:p>
@@ -23428,7 +23428,7 @@
                 <a:ea typeface="Calibri" pitchFamily="34" charset="-122"/>
                 <a:cs typeface="Calibri" pitchFamily="34" charset="-120"/>
               </a:rPr>
-              <a:t>{{CLIENT_SUBDOMAIN}}.onmicrosoft.com</a:t>
+              <a:t>{{CLIENT_SUBDOMAIN}}-terianix.onmicrosoft.com</a:t>
             </a:r>
             <a:endParaRPr lang="en-US" sz="1050" dirty="0"/>
           </a:p>
@@ -23920,7 +23920,7 @@
                 <a:ea typeface="Calibri" pitchFamily="34" charset="-122"/>
                 <a:cs typeface="Calibri" pitchFamily="34" charset="-120"/>
               </a:rPr>
-              <a:t>Your own subdomain under terian-services.com from day one.</a:t>
+              <a:t>Your own subdomain under terianix.ai from day one.</a:t>
             </a:r>
             <a:endParaRPr lang="en-US" sz="950" dirty="0"/>
           </a:p>
@@ -24407,7 +24407,7 @@
                 <a:ea typeface="Calibri" pitchFamily="34" charset="-122"/>
                 <a:cs typeface="Calibri" pitchFamily="34" charset="-120"/>
               </a:rPr>
-              <a:t>Provided by:  Terian Services</a:t>
+              <a:t>Provided by:  Terianix.ai</a:t>
             </a:r>
             <a:endParaRPr lang="en-US" sz="1000" dirty="0"/>
           </a:p>

</xml_diff>